<commit_message>
Category- Working with status change
</commit_message>
<xml_diff>
--- a/.lessons/56 Category, Subcategory and Child Category Setup/7 Category- Working with status change/1.pptx
+++ b/.lessons/56 Category, Subcategory and Child Category Setup/7 Category- Working with status change/1.pptx
@@ -6,8 +6,11 @@
   </p:sldMasterIdLst>
   <p:sldIdLst>
     <p:sldId id="413" r:id="rId2"/>
-    <p:sldId id="414" r:id="rId3"/>
-    <p:sldId id="400" r:id="rId4"/>
+    <p:sldId id="415" r:id="rId3"/>
+    <p:sldId id="416" r:id="rId4"/>
+    <p:sldId id="414" r:id="rId5"/>
+    <p:sldId id="400" r:id="rId6"/>
+    <p:sldId id="420" r:id="rId7"/>
   </p:sldIdLst>
   <p:sldSz cx="12192000" cy="6858000"/>
   <p:notesSz cx="6858000" cy="9144000"/>
@@ -261,7 +264,7 @@
           <a:p>
             <a:fld id="{3E102D2E-813C-461C-9963-687A650C48C0}" type="datetimeFigureOut">
               <a:rPr lang="en-US" smtClean="0"/>
-              <a:t>6/26/2025</a:t>
+              <a:t>8/19/2025</a:t>
             </a:fld>
             <a:endParaRPr lang="en-US"/>
           </a:p>
@@ -459,7 +462,7 @@
           <a:p>
             <a:fld id="{3E102D2E-813C-461C-9963-687A650C48C0}" type="datetimeFigureOut">
               <a:rPr lang="en-US" smtClean="0"/>
-              <a:t>6/26/2025</a:t>
+              <a:t>8/19/2025</a:t>
             </a:fld>
             <a:endParaRPr lang="en-US"/>
           </a:p>
@@ -667,7 +670,7 @@
           <a:p>
             <a:fld id="{3E102D2E-813C-461C-9963-687A650C48C0}" type="datetimeFigureOut">
               <a:rPr lang="en-US" smtClean="0"/>
-              <a:t>6/26/2025</a:t>
+              <a:t>8/19/2025</a:t>
             </a:fld>
             <a:endParaRPr lang="en-US"/>
           </a:p>
@@ -865,7 +868,7 @@
           <a:p>
             <a:fld id="{3E102D2E-813C-461C-9963-687A650C48C0}" type="datetimeFigureOut">
               <a:rPr lang="en-US" smtClean="0"/>
-              <a:t>6/26/2025</a:t>
+              <a:t>8/19/2025</a:t>
             </a:fld>
             <a:endParaRPr lang="en-US"/>
           </a:p>
@@ -1140,7 +1143,7 @@
           <a:p>
             <a:fld id="{3E102D2E-813C-461C-9963-687A650C48C0}" type="datetimeFigureOut">
               <a:rPr lang="en-US" smtClean="0"/>
-              <a:t>6/26/2025</a:t>
+              <a:t>8/19/2025</a:t>
             </a:fld>
             <a:endParaRPr lang="en-US"/>
           </a:p>
@@ -1405,7 +1408,7 @@
           <a:p>
             <a:fld id="{3E102D2E-813C-461C-9963-687A650C48C0}" type="datetimeFigureOut">
               <a:rPr lang="en-US" smtClean="0"/>
-              <a:t>6/26/2025</a:t>
+              <a:t>8/19/2025</a:t>
             </a:fld>
             <a:endParaRPr lang="en-US"/>
           </a:p>
@@ -1817,7 +1820,7 @@
           <a:p>
             <a:fld id="{3E102D2E-813C-461C-9963-687A650C48C0}" type="datetimeFigureOut">
               <a:rPr lang="en-US" smtClean="0"/>
-              <a:t>6/26/2025</a:t>
+              <a:t>8/19/2025</a:t>
             </a:fld>
             <a:endParaRPr lang="en-US"/>
           </a:p>
@@ -1958,7 +1961,7 @@
           <a:p>
             <a:fld id="{3E102D2E-813C-461C-9963-687A650C48C0}" type="datetimeFigureOut">
               <a:rPr lang="en-US" smtClean="0"/>
-              <a:t>6/26/2025</a:t>
+              <a:t>8/19/2025</a:t>
             </a:fld>
             <a:endParaRPr lang="en-US"/>
           </a:p>
@@ -2071,7 +2074,7 @@
           <a:p>
             <a:fld id="{3E102D2E-813C-461C-9963-687A650C48C0}" type="datetimeFigureOut">
               <a:rPr lang="en-US" smtClean="0"/>
-              <a:t>6/26/2025</a:t>
+              <a:t>8/19/2025</a:t>
             </a:fld>
             <a:endParaRPr lang="en-US"/>
           </a:p>
@@ -2382,7 +2385,7 @@
           <a:p>
             <a:fld id="{3E102D2E-813C-461C-9963-687A650C48C0}" type="datetimeFigureOut">
               <a:rPr lang="en-US" smtClean="0"/>
-              <a:t>6/26/2025</a:t>
+              <a:t>8/19/2025</a:t>
             </a:fld>
             <a:endParaRPr lang="en-US"/>
           </a:p>
@@ -2670,7 +2673,7 @@
           <a:p>
             <a:fld id="{3E102D2E-813C-461C-9963-687A650C48C0}" type="datetimeFigureOut">
               <a:rPr lang="en-US" smtClean="0"/>
-              <a:t>6/26/2025</a:t>
+              <a:t>8/19/2025</a:t>
             </a:fld>
             <a:endParaRPr lang="en-US"/>
           </a:p>
@@ -2911,7 +2914,7 @@
           <a:p>
             <a:fld id="{3E102D2E-813C-461C-9963-687A650C48C0}" type="datetimeFigureOut">
               <a:rPr lang="en-US" smtClean="0"/>
-              <a:t>6/26/2025</a:t>
+              <a:t>8/19/2025</a:t>
             </a:fld>
             <a:endParaRPr lang="en-US"/>
           </a:p>
@@ -3349,7 +3352,7 @@
         <p:spPr>
           <a:xfrm>
             <a:off x="217714" y="255046"/>
-            <a:ext cx="11756571" cy="355354"/>
+            <a:ext cx="11756571" cy="3356175"/>
           </a:xfrm>
           <a:prstGeom prst="rect">
             <a:avLst/>
@@ -3369,21 +3372,303 @@
               <a:buNone/>
             </a:pPr>
             <a:r>
-              <a:rPr kumimoji="0" lang="en-US" altLang="en-US" sz="1300" b="0" i="0" u="none" strike="noStrike" cap="none" normalizeH="0" baseline="0">
-                <a:ln>
-                  <a:noFill/>
-                </a:ln>
+              <a:rPr lang="az-Latn-AZ" altLang="en-US" sz="1300">
+                <a:latin typeface="Arial" panose="020B0604020202020204" pitchFamily="34" charset="0"/>
+              </a:rPr>
+              <a:t>Bu dərs, </a:t>
+            </a:r>
+            <a:r>
+              <a:rPr lang="az-Latn-AZ" altLang="en-US" sz="1300" b="1">
                 <a:solidFill>
-                  <a:schemeClr val="tx1"/>
+                  <a:srgbClr val="FF0000"/>
                 </a:solidFill>
-                <a:effectLst/>
-                <a:latin typeface="Arial" panose="020B0604020202020204" pitchFamily="34" charset="0"/>
-              </a:rPr>
-              <a:t>.</a:t>
-            </a:r>
-          </a:p>
-        </p:txBody>
-      </p:sp>
+                <a:latin typeface="Arial" panose="020B0604020202020204" pitchFamily="34" charset="0"/>
+              </a:rPr>
+              <a:t>Category</a:t>
+            </a:r>
+            <a:r>
+              <a:rPr lang="az-Latn-AZ" altLang="en-US" sz="1300">
+                <a:latin typeface="Arial" panose="020B0604020202020204" pitchFamily="34" charset="0"/>
+              </a:rPr>
+              <a:t> </a:t>
+            </a:r>
+            <a:r>
+              <a:rPr lang="az-Latn-AZ" altLang="en-US" sz="1300" b="1">
+                <a:solidFill>
+                  <a:srgbClr val="FF0000"/>
+                </a:solidFill>
+                <a:latin typeface="Arial" panose="020B0604020202020204" pitchFamily="34" charset="0"/>
+              </a:rPr>
+              <a:t>STATUS</a:t>
+            </a:r>
+            <a:r>
+              <a:rPr lang="az-Latn-AZ" altLang="en-US" sz="1300">
+                <a:latin typeface="Arial" panose="020B0604020202020204" pitchFamily="34" charset="0"/>
+              </a:rPr>
+              <a:t> -un dinamik dəyişdirilməsi mövzunu işləyəcəyik.</a:t>
+            </a:r>
+          </a:p>
+          <a:p>
+            <a:pPr>
+              <a:lnSpc>
+                <a:spcPct val="150000"/>
+              </a:lnSpc>
+              <a:buNone/>
+            </a:pPr>
+            <a:endParaRPr kumimoji="0" lang="az-Latn-AZ" altLang="en-US" sz="1300" b="0" i="0" u="none" strike="noStrike" cap="none" normalizeH="0" baseline="0">
+              <a:ln>
+                <a:noFill/>
+              </a:ln>
+              <a:solidFill>
+                <a:schemeClr val="tx1"/>
+              </a:solidFill>
+              <a:effectLst/>
+              <a:latin typeface="Arial" panose="020B0604020202020204" pitchFamily="34" charset="0"/>
+            </a:endParaRPr>
+          </a:p>
+          <a:p>
+            <a:pPr>
+              <a:lnSpc>
+                <a:spcPct val="150000"/>
+              </a:lnSpc>
+              <a:buNone/>
+            </a:pPr>
+            <a:endParaRPr lang="en-US" altLang="en-US" sz="1300">
+              <a:latin typeface="Arial" panose="020B0604020202020204" pitchFamily="34" charset="0"/>
+            </a:endParaRPr>
+          </a:p>
+          <a:p>
+            <a:pPr>
+              <a:lnSpc>
+                <a:spcPct val="150000"/>
+              </a:lnSpc>
+              <a:buNone/>
+            </a:pPr>
+            <a:r>
+              <a:rPr lang="fr-FR" altLang="en-US" sz="1300">
+                <a:latin typeface="Arial" panose="020B0604020202020204" pitchFamily="34" charset="0"/>
+              </a:rPr>
+              <a:t>1️⃣ Route – routes\admin.php</a:t>
+            </a:r>
+          </a:p>
+          <a:p>
+            <a:pPr>
+              <a:lnSpc>
+                <a:spcPct val="150000"/>
+              </a:lnSpc>
+              <a:buNone/>
+            </a:pPr>
+            <a:endParaRPr lang="az-Latn-AZ" altLang="en-US" sz="1300">
+              <a:latin typeface="Arial" panose="020B0604020202020204" pitchFamily="34" charset="0"/>
+            </a:endParaRPr>
+          </a:p>
+          <a:p>
+            <a:pPr>
+              <a:lnSpc>
+                <a:spcPct val="150000"/>
+              </a:lnSpc>
+              <a:buNone/>
+            </a:pPr>
+            <a:r>
+              <a:rPr lang="en-US" altLang="en-US" sz="1300">
+                <a:latin typeface="Arial" panose="020B0604020202020204" pitchFamily="34" charset="0"/>
+              </a:rPr>
+              <a:t>Bu sətir </a:t>
+            </a:r>
+            <a:r>
+              <a:rPr lang="en-US" altLang="en-US" sz="1300" b="1">
+                <a:latin typeface="Arial" panose="020B0604020202020204" pitchFamily="34" charset="0"/>
+              </a:rPr>
+              <a:t>PUT</a:t>
+            </a:r>
+            <a:r>
+              <a:rPr lang="en-US" altLang="en-US" sz="1300">
+                <a:latin typeface="Arial" panose="020B0604020202020204" pitchFamily="34" charset="0"/>
+              </a:rPr>
+              <a:t> request qəbul edən bir route yaradır.</a:t>
+            </a:r>
+          </a:p>
+          <a:p>
+            <a:pPr marL="742950" lvl="1" indent="-285750">
+              <a:lnSpc>
+                <a:spcPct val="150000"/>
+              </a:lnSpc>
+              <a:buFont typeface="Wingdings" panose="05000000000000000000" pitchFamily="2" charset="2"/>
+              <a:buChar char="q"/>
+            </a:pPr>
+            <a:r>
+              <a:rPr lang="en-US" altLang="en-US" sz="1300">
+                <a:latin typeface="Arial" panose="020B0604020202020204" pitchFamily="34" charset="0"/>
+              </a:rPr>
+              <a:t>URL → </a:t>
+            </a:r>
+            <a:r>
+              <a:rPr lang="en-US" altLang="en-US" sz="1300" b="1">
+                <a:latin typeface="Arial" panose="020B0604020202020204" pitchFamily="34" charset="0"/>
+              </a:rPr>
+              <a:t>/change-status</a:t>
+            </a:r>
+          </a:p>
+          <a:p>
+            <a:pPr marL="742950" lvl="1" indent="-285750">
+              <a:lnSpc>
+                <a:spcPct val="150000"/>
+              </a:lnSpc>
+              <a:buFont typeface="Wingdings" panose="05000000000000000000" pitchFamily="2" charset="2"/>
+              <a:buChar char="q"/>
+            </a:pPr>
+            <a:r>
+              <a:rPr lang="en-US" altLang="en-US" sz="1300">
+                <a:latin typeface="Arial" panose="020B0604020202020204" pitchFamily="34" charset="0"/>
+              </a:rPr>
+              <a:t>Controller method → </a:t>
+            </a:r>
+            <a:r>
+              <a:rPr lang="en-US" altLang="en-US" sz="1300" b="1">
+                <a:latin typeface="Arial" panose="020B0604020202020204" pitchFamily="34" charset="0"/>
+              </a:rPr>
+              <a:t>CategoryController@changeStatus</a:t>
+            </a:r>
+          </a:p>
+          <a:p>
+            <a:pPr marL="742950" lvl="1" indent="-285750">
+              <a:lnSpc>
+                <a:spcPct val="150000"/>
+              </a:lnSpc>
+              <a:buFont typeface="Wingdings" panose="05000000000000000000" pitchFamily="2" charset="2"/>
+              <a:buChar char="q"/>
+            </a:pPr>
+            <a:r>
+              <a:rPr lang="en-US" altLang="en-US" sz="1300">
+                <a:latin typeface="Arial" panose="020B0604020202020204" pitchFamily="34" charset="0"/>
+              </a:rPr>
+              <a:t>Route name → </a:t>
+            </a:r>
+            <a:r>
+              <a:rPr lang="en-US" altLang="en-US" sz="1300" b="1">
+                <a:latin typeface="Arial" panose="020B0604020202020204" pitchFamily="34" charset="0"/>
+              </a:rPr>
+              <a:t>admin.category.change-status</a:t>
+            </a:r>
+          </a:p>
+          <a:p>
+            <a:pPr>
+              <a:lnSpc>
+                <a:spcPct val="150000"/>
+              </a:lnSpc>
+              <a:buNone/>
+            </a:pPr>
+            <a:endParaRPr lang="en-US" altLang="en-US" sz="1300">
+              <a:latin typeface="Arial" panose="020B0604020202020204" pitchFamily="34" charset="0"/>
+            </a:endParaRPr>
+          </a:p>
+          <a:p>
+            <a:pPr>
+              <a:lnSpc>
+                <a:spcPct val="150000"/>
+              </a:lnSpc>
+              <a:buNone/>
+            </a:pPr>
+            <a:r>
+              <a:rPr lang="en-US" altLang="en-US" sz="1300">
+                <a:latin typeface="Arial" panose="020B0604020202020204" pitchFamily="34" charset="0"/>
+              </a:rPr>
+              <a:t>Yəni </a:t>
+            </a:r>
+            <a:r>
+              <a:rPr lang="en-US" altLang="en-US" sz="1300" b="1">
+                <a:latin typeface="Arial" panose="020B0604020202020204" pitchFamily="34" charset="0"/>
+              </a:rPr>
+              <a:t>AJAX</a:t>
+            </a:r>
+            <a:r>
+              <a:rPr lang="en-US" altLang="en-US" sz="1300">
+                <a:latin typeface="Arial" panose="020B0604020202020204" pitchFamily="34" charset="0"/>
+              </a:rPr>
+              <a:t> ilə </a:t>
+            </a:r>
+            <a:r>
+              <a:rPr lang="en-US" altLang="en-US" sz="1300" b="1">
+                <a:latin typeface="Arial" panose="020B0604020202020204" pitchFamily="34" charset="0"/>
+              </a:rPr>
+              <a:t>PUT</a:t>
+            </a:r>
+            <a:r>
+              <a:rPr lang="en-US" altLang="en-US" sz="1300">
+                <a:latin typeface="Arial" panose="020B0604020202020204" pitchFamily="34" charset="0"/>
+              </a:rPr>
+              <a:t> </a:t>
+            </a:r>
+            <a:r>
+              <a:rPr lang="en-US" altLang="en-US" sz="1300" b="1">
+                <a:solidFill>
+                  <a:srgbClr val="00B050"/>
+                </a:solidFill>
+                <a:latin typeface="Arial" panose="020B0604020202020204" pitchFamily="34" charset="0"/>
+              </a:rPr>
+              <a:t>request</a:t>
+            </a:r>
+            <a:r>
+              <a:rPr lang="en-US" altLang="en-US" sz="1300">
+                <a:latin typeface="Arial" panose="020B0604020202020204" pitchFamily="34" charset="0"/>
+              </a:rPr>
+              <a:t> göndərsən, Laravel bu </a:t>
+            </a:r>
+            <a:r>
+              <a:rPr lang="en-US" altLang="en-US" sz="1300" b="1">
+                <a:latin typeface="Arial" panose="020B0604020202020204" pitchFamily="34" charset="0"/>
+              </a:rPr>
+              <a:t>methodu</a:t>
+            </a:r>
+            <a:r>
+              <a:rPr lang="en-US" altLang="en-US" sz="1300">
+                <a:latin typeface="Arial" panose="020B0604020202020204" pitchFamily="34" charset="0"/>
+              </a:rPr>
+              <a:t> işlədəcək.</a:t>
+            </a:r>
+            <a:endParaRPr kumimoji="0" lang="en-US" altLang="en-US" sz="1300" b="0" i="0" u="none" strike="noStrike" cap="none" normalizeH="0" baseline="0">
+              <a:ln>
+                <a:noFill/>
+              </a:ln>
+              <a:solidFill>
+                <a:schemeClr val="tx1"/>
+              </a:solidFill>
+              <a:effectLst/>
+              <a:latin typeface="Arial" panose="020B0604020202020204" pitchFamily="34" charset="0"/>
+            </a:endParaRPr>
+          </a:p>
+        </p:txBody>
+      </p:sp>
+      <p:pic>
+        <p:nvPicPr>
+          <p:cNvPr id="4" name="Picture 3">
+            <a:extLst>
+              <a:ext uri="{FF2B5EF4-FFF2-40B4-BE49-F238E27FC236}">
+                <a16:creationId xmlns:a16="http://schemas.microsoft.com/office/drawing/2014/main" id="{945FF63F-D6B9-96DF-98F3-C6E696E869E5}"/>
+              </a:ext>
+            </a:extLst>
+          </p:cNvPr>
+          <p:cNvPicPr>
+            <a:picLocks noChangeAspect="1"/>
+          </p:cNvPicPr>
+          <p:nvPr/>
+        </p:nvPicPr>
+        <p:blipFill>
+          <a:blip r:embed="rId2"/>
+          <a:stretch>
+            <a:fillRect/>
+          </a:stretch>
+        </p:blipFill>
+        <p:spPr>
+          <a:xfrm>
+            <a:off x="6767228" y="0"/>
+            <a:ext cx="5424772" cy="3495964"/>
+          </a:xfrm>
+          <a:prstGeom prst="rect">
+            <a:avLst/>
+          </a:prstGeom>
+        </p:spPr>
+      </p:pic>
     </p:spTree>
     <p:extLst>
       <p:ext uri="{BB962C8B-B14F-4D97-AF65-F5344CB8AC3E}">
@@ -3398,6 +3683,798 @@
 </file>
 
 <file path=ppt/slides/slide2.xml><?xml version="1.0" encoding="utf-8"?>
+<p:sld xmlns:a="http://schemas.openxmlformats.org/drawingml/2006/main" xmlns:r="http://schemas.openxmlformats.org/officeDocument/2006/relationships" xmlns:p="http://schemas.openxmlformats.org/presentationml/2006/main">
+  <p:cSld>
+    <p:spTree>
+      <p:nvGrpSpPr>
+        <p:cNvPr id="1" name="">
+          <a:extLst>
+            <a:ext uri="{FF2B5EF4-FFF2-40B4-BE49-F238E27FC236}">
+              <a16:creationId xmlns:a16="http://schemas.microsoft.com/office/drawing/2014/main" id="{042B346B-F588-E7F5-AC3D-12FF7233730E}"/>
+            </a:ext>
+          </a:extLst>
+        </p:cNvPr>
+        <p:cNvGrpSpPr/>
+        <p:nvPr/>
+      </p:nvGrpSpPr>
+      <p:grpSpPr>
+        <a:xfrm>
+          <a:off x="0" y="0"/>
+          <a:ext cx="0" cy="0"/>
+          <a:chOff x="0" y="0"/>
+          <a:chExt cx="0" cy="0"/>
+        </a:xfrm>
+      </p:grpSpPr>
+      <p:sp>
+        <p:nvSpPr>
+          <p:cNvPr id="3" name="TextBox 2">
+            <a:extLst>
+              <a:ext uri="{FF2B5EF4-FFF2-40B4-BE49-F238E27FC236}">
+                <a16:creationId xmlns:a16="http://schemas.microsoft.com/office/drawing/2014/main" id="{E5A4B6A6-08E4-3106-D8DC-AAE42F0E4FC9}"/>
+              </a:ext>
+            </a:extLst>
+          </p:cNvPr>
+          <p:cNvSpPr txBox="1"/>
+          <p:nvPr/>
+        </p:nvSpPr>
+        <p:spPr>
+          <a:xfrm>
+            <a:off x="217714" y="255046"/>
+            <a:ext cx="11756571" cy="3956339"/>
+          </a:xfrm>
+          <a:prstGeom prst="rect">
+            <a:avLst/>
+          </a:prstGeom>
+          <a:noFill/>
+        </p:spPr>
+        <p:txBody>
+          <a:bodyPr wrap="square">
+            <a:spAutoFit/>
+          </a:bodyPr>
+          <a:lstStyle/>
+          <a:p>
+            <a:pPr>
+              <a:lnSpc>
+                <a:spcPct val="150000"/>
+              </a:lnSpc>
+              <a:buNone/>
+            </a:pPr>
+            <a:r>
+              <a:rPr lang="en-US" altLang="en-US" sz="1300">
+                <a:latin typeface="Arial" panose="020B0604020202020204" pitchFamily="34" charset="0"/>
+              </a:rPr>
+              <a:t>2️⃣ DataTable sütun kodu – app\DataTables\CategoryDataTable.php</a:t>
+            </a:r>
+          </a:p>
+          <a:p>
+            <a:pPr>
+              <a:lnSpc>
+                <a:spcPct val="150000"/>
+              </a:lnSpc>
+              <a:buNone/>
+            </a:pPr>
+            <a:endParaRPr kumimoji="0" lang="en-US" altLang="en-US" sz="1300" b="0" i="0" u="none" strike="noStrike" cap="none" normalizeH="0" baseline="0">
+              <a:ln>
+                <a:noFill/>
+              </a:ln>
+              <a:solidFill>
+                <a:schemeClr val="tx1"/>
+              </a:solidFill>
+              <a:effectLst/>
+              <a:latin typeface="Arial" panose="020B0604020202020204" pitchFamily="34" charset="0"/>
+            </a:endParaRPr>
+          </a:p>
+          <a:p>
+            <a:pPr>
+              <a:lnSpc>
+                <a:spcPct val="150000"/>
+              </a:lnSpc>
+              <a:buNone/>
+            </a:pPr>
+            <a:r>
+              <a:rPr lang="en-US" altLang="en-US" sz="1300">
+                <a:latin typeface="Arial" panose="020B0604020202020204" pitchFamily="34" charset="0"/>
+              </a:rPr>
+              <a:t>Burada hər bir </a:t>
+            </a:r>
+            <a:r>
+              <a:rPr lang="en-US" altLang="en-US" sz="1300" b="1">
+                <a:latin typeface="Arial" panose="020B0604020202020204" pitchFamily="34" charset="0"/>
+              </a:rPr>
+              <a:t>Category</a:t>
+            </a:r>
+            <a:r>
+              <a:rPr lang="en-US" altLang="en-US" sz="1300">
+                <a:latin typeface="Arial" panose="020B0604020202020204" pitchFamily="34" charset="0"/>
+              </a:rPr>
+              <a:t> üçün </a:t>
+            </a:r>
+            <a:r>
+              <a:rPr lang="en-US" altLang="en-US" sz="1300" b="1">
+                <a:latin typeface="Arial" panose="020B0604020202020204" pitchFamily="34" charset="0"/>
+              </a:rPr>
+              <a:t>status</a:t>
+            </a:r>
+            <a:r>
+              <a:rPr lang="en-US" altLang="en-US" sz="1300">
+                <a:latin typeface="Arial" panose="020B0604020202020204" pitchFamily="34" charset="0"/>
+              </a:rPr>
+              <a:t> sütununa </a:t>
+            </a:r>
+            <a:r>
+              <a:rPr lang="en-US" altLang="en-US" sz="1300" b="1">
+                <a:latin typeface="Arial" panose="020B0604020202020204" pitchFamily="34" charset="0"/>
+              </a:rPr>
+              <a:t>checkbox</a:t>
+            </a:r>
+            <a:r>
+              <a:rPr lang="en-US" altLang="en-US" sz="1300">
+                <a:latin typeface="Arial" panose="020B0604020202020204" pitchFamily="34" charset="0"/>
+              </a:rPr>
+              <a:t> qoyulur.</a:t>
+            </a:r>
+          </a:p>
+          <a:p>
+            <a:pPr>
+              <a:lnSpc>
+                <a:spcPct val="150000"/>
+              </a:lnSpc>
+              <a:buNone/>
+            </a:pPr>
+            <a:endParaRPr lang="en-US" altLang="en-US" sz="1300">
+              <a:latin typeface="Arial" panose="020B0604020202020204" pitchFamily="34" charset="0"/>
+            </a:endParaRPr>
+          </a:p>
+          <a:p>
+            <a:pPr>
+              <a:lnSpc>
+                <a:spcPct val="150000"/>
+              </a:lnSpc>
+              <a:buNone/>
+            </a:pPr>
+            <a:r>
+              <a:rPr lang="en-US" altLang="en-US" sz="1300">
+                <a:latin typeface="Arial" panose="020B0604020202020204" pitchFamily="34" charset="0"/>
+              </a:rPr>
+              <a:t>a) </a:t>
+            </a:r>
+            <a:r>
+              <a:rPr lang="en-US" altLang="en-US" sz="1300" b="1">
+                <a:latin typeface="Arial" panose="020B0604020202020204" pitchFamily="34" charset="0"/>
+              </a:rPr>
+              <a:t>data-id="'.$query-&gt;id.'"</a:t>
+            </a:r>
+          </a:p>
+          <a:p>
+            <a:pPr marL="742950" lvl="1" indent="-285750">
+              <a:lnSpc>
+                <a:spcPct val="150000"/>
+              </a:lnSpc>
+              <a:buFont typeface="Wingdings" panose="05000000000000000000" pitchFamily="2" charset="2"/>
+              <a:buChar char="q"/>
+            </a:pPr>
+            <a:r>
+              <a:rPr lang="en-US" altLang="en-US" sz="1300">
+                <a:latin typeface="Arial" panose="020B0604020202020204" pitchFamily="34" charset="0"/>
+              </a:rPr>
+              <a:t>Bu atributla biz hər </a:t>
+            </a:r>
+            <a:r>
+              <a:rPr lang="en-US" altLang="en-US" sz="1300" b="1">
+                <a:latin typeface="Arial" panose="020B0604020202020204" pitchFamily="34" charset="0"/>
+              </a:rPr>
+              <a:t>checkbox</a:t>
+            </a:r>
+            <a:r>
+              <a:rPr lang="en-US" altLang="en-US" sz="1300">
+                <a:latin typeface="Arial" panose="020B0604020202020204" pitchFamily="34" charset="0"/>
+              </a:rPr>
+              <a:t>-a həmin kategoriya </a:t>
+            </a:r>
+            <a:r>
+              <a:rPr lang="en-US" altLang="en-US" sz="1300" b="1">
+                <a:latin typeface="Arial" panose="020B0604020202020204" pitchFamily="34" charset="0"/>
+              </a:rPr>
+              <a:t>ID</a:t>
+            </a:r>
+            <a:r>
+              <a:rPr lang="en-US" altLang="en-US" sz="1300">
+                <a:latin typeface="Arial" panose="020B0604020202020204" pitchFamily="34" charset="0"/>
+              </a:rPr>
+              <a:t>-sini əlavə edirik.</a:t>
+            </a:r>
+          </a:p>
+          <a:p>
+            <a:pPr marL="742950" lvl="1" indent="-285750">
+              <a:lnSpc>
+                <a:spcPct val="150000"/>
+              </a:lnSpc>
+              <a:buFont typeface="Wingdings" panose="05000000000000000000" pitchFamily="2" charset="2"/>
+              <a:buChar char="q"/>
+            </a:pPr>
+            <a:r>
+              <a:rPr lang="en-US" altLang="en-US" sz="1300">
+                <a:latin typeface="Arial" panose="020B0604020202020204" pitchFamily="34" charset="0"/>
+              </a:rPr>
+              <a:t>Sonra </a:t>
+            </a:r>
+            <a:r>
+              <a:rPr lang="en-US" altLang="en-US" sz="1300" b="1">
+                <a:latin typeface="Arial" panose="020B0604020202020204" pitchFamily="34" charset="0"/>
+              </a:rPr>
+              <a:t>JS</a:t>
+            </a:r>
+            <a:r>
+              <a:rPr lang="en-US" altLang="en-US" sz="1300">
+                <a:latin typeface="Arial" panose="020B0604020202020204" pitchFamily="34" charset="0"/>
+              </a:rPr>
+              <a:t> tərəfində </a:t>
+            </a:r>
+            <a:r>
+              <a:rPr lang="en-US" altLang="en-US" sz="1300" b="1">
+                <a:latin typeface="Arial" panose="020B0604020202020204" pitchFamily="34" charset="0"/>
+              </a:rPr>
+              <a:t>$(this).data('id') </a:t>
+            </a:r>
+            <a:r>
+              <a:rPr lang="en-US" altLang="en-US" sz="1300">
+                <a:latin typeface="Arial" panose="020B0604020202020204" pitchFamily="34" charset="0"/>
+              </a:rPr>
+              <a:t>deyə bilirik → bu </a:t>
+            </a:r>
+            <a:r>
+              <a:rPr lang="en-US" altLang="en-US" sz="1300" b="1">
+                <a:latin typeface="Arial" panose="020B0604020202020204" pitchFamily="34" charset="0"/>
+              </a:rPr>
+              <a:t>checkbox</a:t>
+            </a:r>
+            <a:r>
+              <a:rPr lang="en-US" altLang="en-US" sz="1300">
+                <a:latin typeface="Arial" panose="020B0604020202020204" pitchFamily="34" charset="0"/>
+              </a:rPr>
+              <a:t>-un aid olduğu </a:t>
+            </a:r>
+            <a:r>
+              <a:rPr lang="en-US" altLang="en-US" sz="1300" b="1">
+                <a:latin typeface="Arial" panose="020B0604020202020204" pitchFamily="34" charset="0"/>
+              </a:rPr>
+              <a:t>category id</a:t>
+            </a:r>
+            <a:r>
+              <a:rPr lang="en-US" altLang="en-US" sz="1300">
+                <a:latin typeface="Arial" panose="020B0604020202020204" pitchFamily="34" charset="0"/>
+              </a:rPr>
+              <a:t>-ni götürmək üçün.</a:t>
+            </a:r>
+          </a:p>
+          <a:p>
+            <a:pPr>
+              <a:lnSpc>
+                <a:spcPct val="150000"/>
+              </a:lnSpc>
+              <a:buNone/>
+            </a:pPr>
+            <a:endParaRPr lang="en-US" altLang="en-US" sz="1300">
+              <a:latin typeface="Arial" panose="020B0604020202020204" pitchFamily="34" charset="0"/>
+            </a:endParaRPr>
+          </a:p>
+          <a:p>
+            <a:pPr>
+              <a:lnSpc>
+                <a:spcPct val="150000"/>
+              </a:lnSpc>
+              <a:buNone/>
+            </a:pPr>
+            <a:r>
+              <a:rPr lang="en-US" altLang="en-US" sz="1300">
+                <a:latin typeface="Arial" panose="020B0604020202020204" pitchFamily="34" charset="0"/>
+              </a:rPr>
+              <a:t>b) </a:t>
+            </a:r>
+            <a:r>
+              <a:rPr lang="en-US" altLang="en-US" sz="1300" b="1">
+                <a:latin typeface="Arial" panose="020B0604020202020204" pitchFamily="34" charset="0"/>
+              </a:rPr>
+              <a:t>class="custom-switch-input change-status"</a:t>
+            </a:r>
+            <a:endParaRPr lang="en-US" altLang="en-US" sz="1300">
+              <a:latin typeface="Arial" panose="020B0604020202020204" pitchFamily="34" charset="0"/>
+            </a:endParaRPr>
+          </a:p>
+          <a:p>
+            <a:pPr marL="742950" lvl="1" indent="-285750">
+              <a:lnSpc>
+                <a:spcPct val="150000"/>
+              </a:lnSpc>
+              <a:buFont typeface="Wingdings" panose="05000000000000000000" pitchFamily="2" charset="2"/>
+              <a:buChar char="q"/>
+            </a:pPr>
+            <a:r>
+              <a:rPr lang="en-US" altLang="en-US" sz="1300" b="1">
+                <a:latin typeface="Arial" panose="020B0604020202020204" pitchFamily="34" charset="0"/>
+              </a:rPr>
+              <a:t>custom-switch-input</a:t>
+            </a:r>
+            <a:r>
+              <a:rPr lang="en-US" altLang="en-US" sz="1300">
+                <a:latin typeface="Arial" panose="020B0604020202020204" pitchFamily="34" charset="0"/>
+              </a:rPr>
+              <a:t> → dizayn/stylesheet üçündür (CSS ilə işləyir).</a:t>
+            </a:r>
+          </a:p>
+          <a:p>
+            <a:pPr marL="742950" lvl="1" indent="-285750">
+              <a:lnSpc>
+                <a:spcPct val="150000"/>
+              </a:lnSpc>
+              <a:buFont typeface="Wingdings" panose="05000000000000000000" pitchFamily="2" charset="2"/>
+              <a:buChar char="q"/>
+            </a:pPr>
+            <a:r>
+              <a:rPr lang="en-US" altLang="en-US" sz="1300" b="1">
+                <a:latin typeface="Arial" panose="020B0604020202020204" pitchFamily="34" charset="0"/>
+              </a:rPr>
+              <a:t>change-status</a:t>
+            </a:r>
+            <a:r>
+              <a:rPr lang="en-US" altLang="en-US" sz="1300">
+                <a:latin typeface="Arial" panose="020B0604020202020204" pitchFamily="34" charset="0"/>
+              </a:rPr>
+              <a:t> → biz JS-də bu class-a qulaq asırıq:</a:t>
+            </a:r>
+          </a:p>
+          <a:p>
+            <a:pPr>
+              <a:lnSpc>
+                <a:spcPct val="150000"/>
+              </a:lnSpc>
+              <a:buNone/>
+            </a:pPr>
+            <a:endParaRPr kumimoji="0" lang="en-US" altLang="en-US" sz="1300" b="0" i="0" u="none" strike="noStrike" cap="none" normalizeH="0" baseline="0">
+              <a:ln>
+                <a:noFill/>
+              </a:ln>
+              <a:solidFill>
+                <a:schemeClr val="tx1"/>
+              </a:solidFill>
+              <a:effectLst/>
+              <a:latin typeface="Arial" panose="020B0604020202020204" pitchFamily="34" charset="0"/>
+            </a:endParaRPr>
+          </a:p>
+          <a:p>
+            <a:pPr>
+              <a:lnSpc>
+                <a:spcPct val="150000"/>
+              </a:lnSpc>
+              <a:buNone/>
+            </a:pPr>
+            <a:endParaRPr kumimoji="0" lang="en-US" altLang="en-US" sz="1300" b="0" i="0" u="none" strike="noStrike" cap="none" normalizeH="0" baseline="0">
+              <a:ln>
+                <a:noFill/>
+              </a:ln>
+              <a:solidFill>
+                <a:schemeClr val="tx1"/>
+              </a:solidFill>
+              <a:effectLst/>
+              <a:latin typeface="Arial" panose="020B0604020202020204" pitchFamily="34" charset="0"/>
+            </a:endParaRPr>
+          </a:p>
+        </p:txBody>
+      </p:sp>
+      <p:pic>
+        <p:nvPicPr>
+          <p:cNvPr id="4" name="Picture 3">
+            <a:extLst>
+              <a:ext uri="{FF2B5EF4-FFF2-40B4-BE49-F238E27FC236}">
+                <a16:creationId xmlns:a16="http://schemas.microsoft.com/office/drawing/2014/main" id="{111049D8-9179-3466-1095-EF51EC2A9847}"/>
+              </a:ext>
+            </a:extLst>
+          </p:cNvPr>
+          <p:cNvPicPr>
+            <a:picLocks noChangeAspect="1"/>
+          </p:cNvPicPr>
+          <p:nvPr/>
+        </p:nvPicPr>
+        <p:blipFill>
+          <a:blip r:embed="rId2"/>
+          <a:stretch>
+            <a:fillRect/>
+          </a:stretch>
+        </p:blipFill>
+        <p:spPr>
+          <a:xfrm>
+            <a:off x="2733964" y="4607586"/>
+            <a:ext cx="9458036" cy="2250414"/>
+          </a:xfrm>
+          <a:prstGeom prst="rect">
+            <a:avLst/>
+          </a:prstGeom>
+        </p:spPr>
+      </p:pic>
+      <p:pic>
+        <p:nvPicPr>
+          <p:cNvPr id="6" name="Picture 5">
+            <a:extLst>
+              <a:ext uri="{FF2B5EF4-FFF2-40B4-BE49-F238E27FC236}">
+                <a16:creationId xmlns:a16="http://schemas.microsoft.com/office/drawing/2014/main" id="{4D2112F9-913B-04B9-8F2C-EE5F79AFFE6D}"/>
+              </a:ext>
+            </a:extLst>
+          </p:cNvPr>
+          <p:cNvPicPr>
+            <a:picLocks noChangeAspect="1"/>
+          </p:cNvPicPr>
+          <p:nvPr/>
+        </p:nvPicPr>
+        <p:blipFill>
+          <a:blip r:embed="rId3"/>
+          <a:stretch>
+            <a:fillRect/>
+          </a:stretch>
+        </p:blipFill>
+        <p:spPr>
+          <a:xfrm>
+            <a:off x="752487" y="3574362"/>
+            <a:ext cx="3962953" cy="733527"/>
+          </a:xfrm>
+          <a:prstGeom prst="rect">
+            <a:avLst/>
+          </a:prstGeom>
+        </p:spPr>
+      </p:pic>
+    </p:spTree>
+    <p:extLst>
+      <p:ext uri="{BB962C8B-B14F-4D97-AF65-F5344CB8AC3E}">
+        <p14:creationId xmlns:p14="http://schemas.microsoft.com/office/powerpoint/2010/main" val="3635166056"/>
+      </p:ext>
+    </p:extLst>
+  </p:cSld>
+  <p:clrMapOvr>
+    <a:masterClrMapping/>
+  </p:clrMapOvr>
+</p:sld>
+</file>
+
+<file path=ppt/slides/slide3.xml><?xml version="1.0" encoding="utf-8"?>
+<p:sld xmlns:a="http://schemas.openxmlformats.org/drawingml/2006/main" xmlns:r="http://schemas.openxmlformats.org/officeDocument/2006/relationships" xmlns:p="http://schemas.openxmlformats.org/presentationml/2006/main">
+  <p:cSld>
+    <p:spTree>
+      <p:nvGrpSpPr>
+        <p:cNvPr id="1" name="">
+          <a:extLst>
+            <a:ext uri="{FF2B5EF4-FFF2-40B4-BE49-F238E27FC236}">
+              <a16:creationId xmlns:a16="http://schemas.microsoft.com/office/drawing/2014/main" id="{796EBA62-F201-1FEF-6864-8BB136325802}"/>
+            </a:ext>
+          </a:extLst>
+        </p:cNvPr>
+        <p:cNvGrpSpPr/>
+        <p:nvPr/>
+      </p:nvGrpSpPr>
+      <p:grpSpPr>
+        <a:xfrm>
+          <a:off x="0" y="0"/>
+          <a:ext cx="0" cy="0"/>
+          <a:chOff x="0" y="0"/>
+          <a:chExt cx="0" cy="0"/>
+        </a:xfrm>
+      </p:grpSpPr>
+      <p:sp>
+        <p:nvSpPr>
+          <p:cNvPr id="3" name="TextBox 2">
+            <a:extLst>
+              <a:ext uri="{FF2B5EF4-FFF2-40B4-BE49-F238E27FC236}">
+                <a16:creationId xmlns:a16="http://schemas.microsoft.com/office/drawing/2014/main" id="{F3A7B5D7-C0C9-0D70-9941-521FB419B463}"/>
+              </a:ext>
+            </a:extLst>
+          </p:cNvPr>
+          <p:cNvSpPr txBox="1"/>
+          <p:nvPr/>
+        </p:nvSpPr>
+        <p:spPr>
+          <a:xfrm>
+            <a:off x="217714" y="255046"/>
+            <a:ext cx="11756571" cy="3356175"/>
+          </a:xfrm>
+          <a:prstGeom prst="rect">
+            <a:avLst/>
+          </a:prstGeom>
+          <a:noFill/>
+        </p:spPr>
+        <p:txBody>
+          <a:bodyPr wrap="square">
+            <a:spAutoFit/>
+          </a:bodyPr>
+          <a:lstStyle/>
+          <a:p>
+            <a:pPr>
+              <a:lnSpc>
+                <a:spcPct val="150000"/>
+              </a:lnSpc>
+              <a:buNone/>
+            </a:pPr>
+            <a:r>
+              <a:rPr lang="en-US" altLang="en-US" sz="1300">
+                <a:latin typeface="Arial" panose="020B0604020202020204" pitchFamily="34" charset="0"/>
+              </a:rPr>
+              <a:t>3️⃣ Blade – resources\views\admin\category\index.blade.php</a:t>
+            </a:r>
+          </a:p>
+          <a:p>
+            <a:pPr>
+              <a:lnSpc>
+                <a:spcPct val="150000"/>
+              </a:lnSpc>
+              <a:buNone/>
+            </a:pPr>
+            <a:endParaRPr kumimoji="0" lang="en-US" altLang="en-US" sz="1300" b="0" i="0" u="none" strike="noStrike" cap="none" normalizeH="0" baseline="0">
+              <a:ln>
+                <a:noFill/>
+              </a:ln>
+              <a:solidFill>
+                <a:schemeClr val="tx1"/>
+              </a:solidFill>
+              <a:effectLst/>
+              <a:latin typeface="Arial" panose="020B0604020202020204" pitchFamily="34" charset="0"/>
+            </a:endParaRPr>
+          </a:p>
+          <a:p>
+            <a:pPr>
+              <a:lnSpc>
+                <a:spcPct val="150000"/>
+              </a:lnSpc>
+              <a:buNone/>
+            </a:pPr>
+            <a:endParaRPr lang="en-US" altLang="en-US" sz="1300">
+              <a:latin typeface="Arial" panose="020B0604020202020204" pitchFamily="34" charset="0"/>
+            </a:endParaRPr>
+          </a:p>
+          <a:p>
+            <a:pPr>
+              <a:lnSpc>
+                <a:spcPct val="150000"/>
+              </a:lnSpc>
+              <a:buNone/>
+            </a:pPr>
+            <a:r>
+              <a:rPr lang="en-US" altLang="en-US" sz="1300">
+                <a:latin typeface="Arial" panose="020B0604020202020204" pitchFamily="34" charset="0"/>
+              </a:rPr>
+              <a:t>➡️ Bu script checkbox kliklənəndə işə düşür.</a:t>
+            </a:r>
+          </a:p>
+          <a:p>
+            <a:pPr lvl="1">
+              <a:lnSpc>
+                <a:spcPct val="150000"/>
+              </a:lnSpc>
+            </a:pPr>
+            <a:r>
+              <a:rPr lang="en-US" altLang="en-US" sz="1300">
+                <a:latin typeface="Arial" panose="020B0604020202020204" pitchFamily="34" charset="0"/>
+              </a:rPr>
+              <a:t>1) </a:t>
+            </a:r>
+            <a:r>
+              <a:rPr lang="en-US" altLang="en-US" sz="1300" b="1">
+                <a:latin typeface="Arial" panose="020B0604020202020204" pitchFamily="34" charset="0"/>
+              </a:rPr>
+              <a:t>Checkbox</a:t>
+            </a:r>
+            <a:r>
+              <a:rPr lang="en-US" altLang="en-US" sz="1300">
+                <a:latin typeface="Arial" panose="020B0604020202020204" pitchFamily="34" charset="0"/>
+              </a:rPr>
+              <a:t>-un seçilib–seçilmədiyini yoxlayır.</a:t>
+            </a:r>
+          </a:p>
+          <a:p>
+            <a:pPr lvl="1">
+              <a:lnSpc>
+                <a:spcPct val="150000"/>
+              </a:lnSpc>
+            </a:pPr>
+            <a:r>
+              <a:rPr lang="en-US" altLang="en-US" sz="1300">
+                <a:latin typeface="Arial" panose="020B0604020202020204" pitchFamily="34" charset="0"/>
+              </a:rPr>
+              <a:t>2) </a:t>
+            </a:r>
+            <a:r>
+              <a:rPr lang="en-US" altLang="en-US" sz="1300" b="1">
+                <a:latin typeface="Arial" panose="020B0604020202020204" pitchFamily="34" charset="0"/>
+              </a:rPr>
+              <a:t>data-id</a:t>
+            </a:r>
+            <a:r>
+              <a:rPr lang="en-US" altLang="en-US" sz="1300">
+                <a:latin typeface="Arial" panose="020B0604020202020204" pitchFamily="34" charset="0"/>
+              </a:rPr>
+              <a:t> vasitəsilə category id-ni götürür.</a:t>
+            </a:r>
+          </a:p>
+          <a:p>
+            <a:pPr lvl="1">
+              <a:lnSpc>
+                <a:spcPct val="150000"/>
+              </a:lnSpc>
+            </a:pPr>
+            <a:r>
+              <a:rPr lang="en-US" altLang="en-US" sz="1300">
+                <a:latin typeface="Arial" panose="020B0604020202020204" pitchFamily="34" charset="0"/>
+              </a:rPr>
+              <a:t>3) PUT AJAX request göndərir → serverə </a:t>
+            </a:r>
+            <a:r>
+              <a:rPr lang="en-US" altLang="en-US" sz="1300" b="1">
+                <a:latin typeface="Arial" panose="020B0604020202020204" pitchFamily="34" charset="0"/>
+              </a:rPr>
+              <a:t>id</a:t>
+            </a:r>
+            <a:r>
+              <a:rPr lang="en-US" altLang="en-US" sz="1300">
+                <a:latin typeface="Arial" panose="020B0604020202020204" pitchFamily="34" charset="0"/>
+              </a:rPr>
+              <a:t> və </a:t>
+            </a:r>
+            <a:r>
+              <a:rPr lang="en-US" altLang="en-US" sz="1300" b="1">
+                <a:latin typeface="Arial" panose="020B0604020202020204" pitchFamily="34" charset="0"/>
+              </a:rPr>
+              <a:t>isChecked</a:t>
+            </a:r>
+            <a:r>
+              <a:rPr lang="en-US" altLang="en-US" sz="1300">
+                <a:latin typeface="Arial" panose="020B0604020202020204" pitchFamily="34" charset="0"/>
+              </a:rPr>
+              <a:t>.</a:t>
+            </a:r>
+          </a:p>
+          <a:p>
+            <a:pPr>
+              <a:lnSpc>
+                <a:spcPct val="150000"/>
+              </a:lnSpc>
+              <a:buNone/>
+            </a:pPr>
+            <a:endParaRPr kumimoji="0" lang="en-US" altLang="en-US" sz="1300" b="0" i="0" u="none" strike="noStrike" cap="none" normalizeH="0" baseline="0">
+              <a:ln>
+                <a:noFill/>
+              </a:ln>
+              <a:solidFill>
+                <a:schemeClr val="tx1"/>
+              </a:solidFill>
+              <a:effectLst/>
+              <a:latin typeface="Arial" panose="020B0604020202020204" pitchFamily="34" charset="0"/>
+            </a:endParaRPr>
+          </a:p>
+          <a:p>
+            <a:pPr>
+              <a:lnSpc>
+                <a:spcPct val="150000"/>
+              </a:lnSpc>
+              <a:buNone/>
+            </a:pPr>
+            <a:endParaRPr lang="en-US" altLang="en-US" sz="1300">
+              <a:latin typeface="Arial" panose="020B0604020202020204" pitchFamily="34" charset="0"/>
+            </a:endParaRPr>
+          </a:p>
+          <a:p>
+            <a:pPr>
+              <a:lnSpc>
+                <a:spcPct val="150000"/>
+              </a:lnSpc>
+              <a:buNone/>
+            </a:pPr>
+            <a:endParaRPr kumimoji="0" lang="en-US" altLang="en-US" sz="1300" b="0" i="0" u="none" strike="noStrike" cap="none" normalizeH="0" baseline="0">
+              <a:ln>
+                <a:noFill/>
+              </a:ln>
+              <a:solidFill>
+                <a:schemeClr val="tx1"/>
+              </a:solidFill>
+              <a:effectLst/>
+              <a:latin typeface="Arial" panose="020B0604020202020204" pitchFamily="34" charset="0"/>
+            </a:endParaRPr>
+          </a:p>
+          <a:p>
+            <a:pPr>
+              <a:lnSpc>
+                <a:spcPct val="150000"/>
+              </a:lnSpc>
+              <a:buNone/>
+            </a:pPr>
+            <a:r>
+              <a:rPr lang="az-Latn-AZ" altLang="en-US" sz="1300">
+                <a:latin typeface="Arial" panose="020B0604020202020204" pitchFamily="34" charset="0"/>
+              </a:rPr>
+              <a:t>Buda kodun tam şəkli. Toastr ilə olan tam halı.</a:t>
+            </a:r>
+            <a:endParaRPr kumimoji="0" lang="en-US" altLang="en-US" sz="1300" i="0" u="none" strike="noStrike" cap="none" normalizeH="0" baseline="0">
+              <a:ln>
+                <a:noFill/>
+              </a:ln>
+              <a:solidFill>
+                <a:schemeClr val="tx1"/>
+              </a:solidFill>
+              <a:effectLst/>
+              <a:latin typeface="Arial" panose="020B0604020202020204" pitchFamily="34" charset="0"/>
+            </a:endParaRPr>
+          </a:p>
+        </p:txBody>
+      </p:sp>
+      <p:pic>
+        <p:nvPicPr>
+          <p:cNvPr id="4" name="Picture 3">
+            <a:extLst>
+              <a:ext uri="{FF2B5EF4-FFF2-40B4-BE49-F238E27FC236}">
+                <a16:creationId xmlns:a16="http://schemas.microsoft.com/office/drawing/2014/main" id="{E0DE6DF9-DC1A-9AF3-2F50-41FC65FC7095}"/>
+              </a:ext>
+            </a:extLst>
+          </p:cNvPr>
+          <p:cNvPicPr>
+            <a:picLocks noChangeAspect="1"/>
+          </p:cNvPicPr>
+          <p:nvPr/>
+        </p:nvPicPr>
+        <p:blipFill>
+          <a:blip r:embed="rId2"/>
+          <a:stretch>
+            <a:fillRect/>
+          </a:stretch>
+        </p:blipFill>
+        <p:spPr>
+          <a:xfrm>
+            <a:off x="5571201" y="0"/>
+            <a:ext cx="6620799" cy="5420481"/>
+          </a:xfrm>
+          <a:prstGeom prst="rect">
+            <a:avLst/>
+          </a:prstGeom>
+        </p:spPr>
+      </p:pic>
+      <p:pic>
+        <p:nvPicPr>
+          <p:cNvPr id="6" name="Picture 5">
+            <a:extLst>
+              <a:ext uri="{FF2B5EF4-FFF2-40B4-BE49-F238E27FC236}">
+                <a16:creationId xmlns:a16="http://schemas.microsoft.com/office/drawing/2014/main" id="{915D3EA1-27C9-6670-7C8E-201A32EE5D97}"/>
+              </a:ext>
+            </a:extLst>
+          </p:cNvPr>
+          <p:cNvPicPr>
+            <a:picLocks noChangeAspect="1"/>
+          </p:cNvPicPr>
+          <p:nvPr/>
+        </p:nvPicPr>
+        <p:blipFill>
+          <a:blip r:embed="rId3"/>
+          <a:stretch>
+            <a:fillRect/>
+          </a:stretch>
+        </p:blipFill>
+        <p:spPr>
+          <a:xfrm>
+            <a:off x="1" y="3703782"/>
+            <a:ext cx="3109932" cy="3154218"/>
+          </a:xfrm>
+          <a:prstGeom prst="rect">
+            <a:avLst/>
+          </a:prstGeom>
+        </p:spPr>
+      </p:pic>
+    </p:spTree>
+    <p:extLst>
+      <p:ext uri="{BB962C8B-B14F-4D97-AF65-F5344CB8AC3E}">
+        <p14:creationId xmlns:p14="http://schemas.microsoft.com/office/powerpoint/2010/main" val="3963359505"/>
+      </p:ext>
+    </p:extLst>
+  </p:cSld>
+  <p:clrMapOvr>
+    <a:masterClrMapping/>
+  </p:clrMapOvr>
+</p:sld>
+</file>
+
+<file path=ppt/slides/slide4.xml><?xml version="1.0" encoding="utf-8"?>
 <p:sld xmlns:a="http://schemas.openxmlformats.org/drawingml/2006/main" xmlns:r="http://schemas.openxmlformats.org/officeDocument/2006/relationships" xmlns:p="http://schemas.openxmlformats.org/presentationml/2006/main">
   <p:cSld>
     <p:spTree>
@@ -3435,7 +4512,7 @@
         <p:spPr>
           <a:xfrm>
             <a:off x="217714" y="255046"/>
-            <a:ext cx="11756571" cy="355354"/>
+            <a:ext cx="11756571" cy="5756832"/>
           </a:xfrm>
           <a:prstGeom prst="rect">
             <a:avLst/>
@@ -3455,21 +4532,307 @@
               <a:buNone/>
             </a:pPr>
             <a:r>
-              <a:rPr kumimoji="0" lang="en-US" altLang="en-US" sz="1300" b="0" i="0" u="none" strike="noStrike" cap="none" normalizeH="0" baseline="0">
-                <a:ln>
-                  <a:noFill/>
-                </a:ln>
-                <a:solidFill>
-                  <a:schemeClr val="tx1"/>
-                </a:solidFill>
-                <a:effectLst/>
-                <a:latin typeface="Arial" panose="020B0604020202020204" pitchFamily="34" charset="0"/>
-              </a:rPr>
-              <a:t>.</a:t>
-            </a:r>
-          </a:p>
-        </p:txBody>
-      </p:sp>
+              <a:rPr lang="en-US" altLang="en-US" sz="1300">
+                <a:latin typeface="Arial" panose="020B0604020202020204" pitchFamily="34" charset="0"/>
+              </a:rPr>
+              <a:t>4️⃣ Controller – app\Http\Controllers\Backend\CategoryController.php</a:t>
+            </a:r>
+          </a:p>
+          <a:p>
+            <a:pPr>
+              <a:lnSpc>
+                <a:spcPct val="150000"/>
+              </a:lnSpc>
+              <a:buNone/>
+            </a:pPr>
+            <a:endParaRPr kumimoji="0" lang="en-US" altLang="en-US" sz="1300" b="0" i="0" u="none" strike="noStrike" cap="none" normalizeH="0" baseline="0">
+              <a:ln>
+                <a:noFill/>
+              </a:ln>
+              <a:solidFill>
+                <a:schemeClr val="tx1"/>
+              </a:solidFill>
+              <a:effectLst/>
+              <a:latin typeface="Arial" panose="020B0604020202020204" pitchFamily="34" charset="0"/>
+            </a:endParaRPr>
+          </a:p>
+          <a:p>
+            <a:pPr>
+              <a:lnSpc>
+                <a:spcPct val="150000"/>
+              </a:lnSpc>
+              <a:buNone/>
+            </a:pPr>
+            <a:endParaRPr lang="en-US" altLang="en-US" sz="1300">
+              <a:latin typeface="Arial" panose="020B0604020202020204" pitchFamily="34" charset="0"/>
+            </a:endParaRPr>
+          </a:p>
+          <a:p>
+            <a:pPr>
+              <a:lnSpc>
+                <a:spcPct val="150000"/>
+              </a:lnSpc>
+              <a:buNone/>
+            </a:pPr>
+            <a:endParaRPr kumimoji="0" lang="en-US" altLang="en-US" sz="1300" b="0" i="0" u="none" strike="noStrike" cap="none" normalizeH="0" baseline="0">
+              <a:ln>
+                <a:noFill/>
+              </a:ln>
+              <a:solidFill>
+                <a:schemeClr val="tx1"/>
+              </a:solidFill>
+              <a:effectLst/>
+              <a:latin typeface="Arial" panose="020B0604020202020204" pitchFamily="34" charset="0"/>
+            </a:endParaRPr>
+          </a:p>
+          <a:p>
+            <a:pPr>
+              <a:lnSpc>
+                <a:spcPct val="150000"/>
+              </a:lnSpc>
+              <a:buNone/>
+            </a:pPr>
+            <a:endParaRPr lang="en-US" altLang="en-US" sz="1300">
+              <a:latin typeface="Arial" panose="020B0604020202020204" pitchFamily="34" charset="0"/>
+            </a:endParaRPr>
+          </a:p>
+          <a:p>
+            <a:pPr>
+              <a:lnSpc>
+                <a:spcPct val="150000"/>
+              </a:lnSpc>
+              <a:buNone/>
+            </a:pPr>
+            <a:endParaRPr kumimoji="0" lang="en-US" altLang="en-US" sz="1300" b="0" i="0" u="none" strike="noStrike" cap="none" normalizeH="0" baseline="0">
+              <a:ln>
+                <a:noFill/>
+              </a:ln>
+              <a:solidFill>
+                <a:schemeClr val="tx1"/>
+              </a:solidFill>
+              <a:effectLst/>
+              <a:latin typeface="Arial" panose="020B0604020202020204" pitchFamily="34" charset="0"/>
+            </a:endParaRPr>
+          </a:p>
+          <a:p>
+            <a:pPr>
+              <a:lnSpc>
+                <a:spcPct val="150000"/>
+              </a:lnSpc>
+              <a:buNone/>
+            </a:pPr>
+            <a:endParaRPr lang="en-US" altLang="en-US" sz="1300">
+              <a:latin typeface="Arial" panose="020B0604020202020204" pitchFamily="34" charset="0"/>
+            </a:endParaRPr>
+          </a:p>
+          <a:p>
+            <a:pPr>
+              <a:lnSpc>
+                <a:spcPct val="150000"/>
+              </a:lnSpc>
+              <a:buNone/>
+            </a:pPr>
+            <a:endParaRPr kumimoji="0" lang="en-US" altLang="en-US" sz="1300" b="0" i="0" u="none" strike="noStrike" cap="none" normalizeH="0" baseline="0">
+              <a:ln>
+                <a:noFill/>
+              </a:ln>
+              <a:solidFill>
+                <a:schemeClr val="tx1"/>
+              </a:solidFill>
+              <a:effectLst/>
+              <a:latin typeface="Arial" panose="020B0604020202020204" pitchFamily="34" charset="0"/>
+            </a:endParaRPr>
+          </a:p>
+          <a:p>
+            <a:pPr>
+              <a:lnSpc>
+                <a:spcPct val="150000"/>
+              </a:lnSpc>
+              <a:buNone/>
+            </a:pPr>
+            <a:endParaRPr lang="en-US" altLang="en-US" sz="1300">
+              <a:latin typeface="Arial" panose="020B0604020202020204" pitchFamily="34" charset="0"/>
+            </a:endParaRPr>
+          </a:p>
+          <a:p>
+            <a:pPr>
+              <a:lnSpc>
+                <a:spcPct val="150000"/>
+              </a:lnSpc>
+              <a:buNone/>
+            </a:pPr>
+            <a:r>
+              <a:rPr lang="en-US" altLang="en-US" sz="1300">
+                <a:latin typeface="Arial" panose="020B0604020202020204" pitchFamily="34" charset="0"/>
+              </a:rPr>
+              <a:t>➡️ Bu method AJAX-dan gələn məlumatı alır:</a:t>
+            </a:r>
+          </a:p>
+          <a:p>
+            <a:pPr marL="742950" lvl="1" indent="-285750">
+              <a:lnSpc>
+                <a:spcPct val="150000"/>
+              </a:lnSpc>
+              <a:buFont typeface="Wingdings" panose="05000000000000000000" pitchFamily="2" charset="2"/>
+              <a:buChar char="q"/>
+            </a:pPr>
+            <a:r>
+              <a:rPr lang="en-US" altLang="en-US" sz="1300">
+                <a:latin typeface="Arial" panose="020B0604020202020204" pitchFamily="34" charset="0"/>
+              </a:rPr>
+              <a:t>id → hansı category</a:t>
+            </a:r>
+          </a:p>
+          <a:p>
+            <a:pPr marL="742950" lvl="1" indent="-285750">
+              <a:lnSpc>
+                <a:spcPct val="150000"/>
+              </a:lnSpc>
+              <a:buFont typeface="Wingdings" panose="05000000000000000000" pitchFamily="2" charset="2"/>
+              <a:buChar char="q"/>
+            </a:pPr>
+            <a:r>
+              <a:rPr lang="en-US" altLang="en-US" sz="1300">
+                <a:latin typeface="Arial" panose="020B0604020202020204" pitchFamily="34" charset="0"/>
+              </a:rPr>
+              <a:t>isChecked → true/false (checkbox seçilib ya yox)</a:t>
+            </a:r>
+          </a:p>
+          <a:p>
+            <a:pPr>
+              <a:lnSpc>
+                <a:spcPct val="150000"/>
+              </a:lnSpc>
+              <a:buNone/>
+            </a:pPr>
+            <a:endParaRPr lang="en-US" altLang="en-US" sz="1300">
+              <a:latin typeface="Arial" panose="020B0604020202020204" pitchFamily="34" charset="0"/>
+            </a:endParaRPr>
+          </a:p>
+          <a:p>
+            <a:pPr>
+              <a:lnSpc>
+                <a:spcPct val="150000"/>
+              </a:lnSpc>
+              <a:buNone/>
+            </a:pPr>
+            <a:r>
+              <a:rPr lang="en-US" altLang="en-US" sz="1300">
+                <a:latin typeface="Arial" panose="020B0604020202020204" pitchFamily="34" charset="0"/>
+              </a:rPr>
+              <a:t>Sonra:</a:t>
+            </a:r>
+          </a:p>
+          <a:p>
+            <a:pPr marL="800100" lvl="1" indent="-342900">
+              <a:lnSpc>
+                <a:spcPct val="150000"/>
+              </a:lnSpc>
+              <a:buFont typeface="Wingdings" panose="05000000000000000000" pitchFamily="2" charset="2"/>
+              <a:buChar char="q"/>
+            </a:pPr>
+            <a:r>
+              <a:rPr lang="en-US" altLang="en-US" sz="1300">
+                <a:latin typeface="Arial" panose="020B0604020202020204" pitchFamily="34" charset="0"/>
+              </a:rPr>
+              <a:t>Həmin category tapılır.</a:t>
+            </a:r>
+          </a:p>
+          <a:p>
+            <a:pPr marL="800100" lvl="1" indent="-342900">
+              <a:lnSpc>
+                <a:spcPct val="150000"/>
+              </a:lnSpc>
+              <a:buFont typeface="Wingdings" panose="05000000000000000000" pitchFamily="2" charset="2"/>
+              <a:buChar char="q"/>
+            </a:pPr>
+            <a:r>
+              <a:rPr lang="en-US" altLang="en-US" sz="1300">
+                <a:latin typeface="Arial" panose="020B0604020202020204" pitchFamily="34" charset="0"/>
+              </a:rPr>
+              <a:t>status dəyəri 1 və ya 0 olaraq yenilənir.</a:t>
+            </a:r>
+          </a:p>
+          <a:p>
+            <a:pPr marL="800100" lvl="1" indent="-342900">
+              <a:lnSpc>
+                <a:spcPct val="150000"/>
+              </a:lnSpc>
+              <a:buFont typeface="Wingdings" panose="05000000000000000000" pitchFamily="2" charset="2"/>
+              <a:buChar char="q"/>
+            </a:pPr>
+            <a:r>
+              <a:rPr lang="en-US" altLang="en-US" sz="1300">
+                <a:latin typeface="Arial" panose="020B0604020202020204" pitchFamily="34" charset="0"/>
+              </a:rPr>
+              <a:t>DB-yə save olunur.</a:t>
+            </a:r>
+          </a:p>
+          <a:p>
+            <a:pPr marL="800100" lvl="1" indent="-342900">
+              <a:lnSpc>
+                <a:spcPct val="150000"/>
+              </a:lnSpc>
+              <a:buFont typeface="Wingdings" panose="05000000000000000000" pitchFamily="2" charset="2"/>
+              <a:buChar char="q"/>
+            </a:pPr>
+            <a:r>
+              <a:rPr lang="en-US" altLang="en-US" sz="1300">
+                <a:latin typeface="Arial" panose="020B0604020202020204" pitchFamily="34" charset="0"/>
+              </a:rPr>
+              <a:t>AJAX-a cavab göndərilir: "Status has been updated!".</a:t>
+            </a:r>
+          </a:p>
+          <a:p>
+            <a:pPr>
+              <a:lnSpc>
+                <a:spcPct val="150000"/>
+              </a:lnSpc>
+              <a:buNone/>
+            </a:pPr>
+            <a:endParaRPr kumimoji="0" lang="en-US" altLang="en-US" sz="1300" b="0" i="0" u="none" strike="noStrike" cap="none" normalizeH="0" baseline="0">
+              <a:ln>
+                <a:noFill/>
+              </a:ln>
+              <a:solidFill>
+                <a:schemeClr val="tx1"/>
+              </a:solidFill>
+              <a:effectLst/>
+              <a:latin typeface="Arial" panose="020B0604020202020204" pitchFamily="34" charset="0"/>
+            </a:endParaRPr>
+          </a:p>
+        </p:txBody>
+      </p:sp>
+      <p:pic>
+        <p:nvPicPr>
+          <p:cNvPr id="4" name="Picture 3">
+            <a:extLst>
+              <a:ext uri="{FF2B5EF4-FFF2-40B4-BE49-F238E27FC236}">
+                <a16:creationId xmlns:a16="http://schemas.microsoft.com/office/drawing/2014/main" id="{7CCF5464-AADC-F864-7C53-2D412D6767C7}"/>
+              </a:ext>
+            </a:extLst>
+          </p:cNvPr>
+          <p:cNvPicPr>
+            <a:picLocks noChangeAspect="1"/>
+          </p:cNvPicPr>
+          <p:nvPr/>
+        </p:nvPicPr>
+        <p:blipFill>
+          <a:blip r:embed="rId2"/>
+          <a:stretch>
+            <a:fillRect/>
+          </a:stretch>
+        </p:blipFill>
+        <p:spPr>
+          <a:xfrm>
+            <a:off x="0" y="761426"/>
+            <a:ext cx="6906589" cy="2010056"/>
+          </a:xfrm>
+          <a:prstGeom prst="rect">
+            <a:avLst/>
+          </a:prstGeom>
+        </p:spPr>
+      </p:pic>
     </p:spTree>
     <p:extLst>
       <p:ext uri="{BB962C8B-B14F-4D97-AF65-F5344CB8AC3E}">
@@ -3483,7 +4846,7 @@
 </p:sld>
 </file>
 
-<file path=ppt/slides/slide3.xml><?xml version="1.0" encoding="utf-8"?>
+<file path=ppt/slides/slide5.xml><?xml version="1.0" encoding="utf-8"?>
 <p:sld xmlns:a="http://schemas.openxmlformats.org/drawingml/2006/main" xmlns:r="http://schemas.openxmlformats.org/officeDocument/2006/relationships" xmlns:p="http://schemas.openxmlformats.org/presentationml/2006/main">
   <p:cSld>
     <p:spTree>
@@ -3521,6 +4884,217 @@
         <p:spPr>
           <a:xfrm>
             <a:off x="217714" y="255046"/>
+            <a:ext cx="11756571" cy="2756011"/>
+          </a:xfrm>
+          <a:prstGeom prst="rect">
+            <a:avLst/>
+          </a:prstGeom>
+          <a:noFill/>
+        </p:spPr>
+        <p:txBody>
+          <a:bodyPr wrap="square">
+            <a:spAutoFit/>
+          </a:bodyPr>
+          <a:lstStyle/>
+          <a:p>
+            <a:pPr>
+              <a:lnSpc>
+                <a:spcPct val="150000"/>
+              </a:lnSpc>
+              <a:buNone/>
+            </a:pPr>
+            <a:r>
+              <a:rPr lang="en-US" altLang="en-US" sz="1300" b="1">
+                <a:latin typeface="Arial" panose="020B0604020202020204" pitchFamily="34" charset="0"/>
+              </a:rPr>
+              <a:t>Qısaca bütün proses</a:t>
+            </a:r>
+            <a:r>
+              <a:rPr lang="en-US" altLang="en-US" sz="1300">
+                <a:latin typeface="Arial" panose="020B0604020202020204" pitchFamily="34" charset="0"/>
+              </a:rPr>
+              <a:t>:</a:t>
+            </a:r>
+          </a:p>
+          <a:p>
+            <a:pPr marL="800100" lvl="1" indent="-342900">
+              <a:lnSpc>
+                <a:spcPct val="150000"/>
+              </a:lnSpc>
+              <a:buFont typeface="+mj-lt"/>
+              <a:buAutoNum type="arabicPeriod"/>
+            </a:pPr>
+            <a:r>
+              <a:rPr lang="en-US" altLang="en-US" sz="1300">
+                <a:latin typeface="Arial" panose="020B0604020202020204" pitchFamily="34" charset="0"/>
+              </a:rPr>
+              <a:t>DataTable-də hər category yanında checkbox göstərilir (status).</a:t>
+            </a:r>
+          </a:p>
+          <a:p>
+            <a:pPr marL="800100" lvl="1" indent="-342900">
+              <a:lnSpc>
+                <a:spcPct val="150000"/>
+              </a:lnSpc>
+              <a:buFont typeface="+mj-lt"/>
+              <a:buAutoNum type="arabicPeriod"/>
+            </a:pPr>
+            <a:r>
+              <a:rPr lang="en-US" altLang="en-US" sz="1300">
+                <a:latin typeface="Arial" panose="020B0604020202020204" pitchFamily="34" charset="0"/>
+              </a:rPr>
+              <a:t>Hər checkbox-a həmin category ID-si (data-id) qoyulur.</a:t>
+            </a:r>
+          </a:p>
+          <a:p>
+            <a:pPr marL="800100" lvl="1" indent="-342900">
+              <a:lnSpc>
+                <a:spcPct val="150000"/>
+              </a:lnSpc>
+              <a:buFont typeface="+mj-lt"/>
+              <a:buAutoNum type="arabicPeriod"/>
+            </a:pPr>
+            <a:r>
+              <a:rPr lang="en-US" altLang="en-US" sz="1300">
+                <a:latin typeface="Arial" panose="020B0604020202020204" pitchFamily="34" charset="0"/>
+              </a:rPr>
+              <a:t>change-status class-ı ilə JS həmin checkbox-u tanıyır.</a:t>
+            </a:r>
+          </a:p>
+          <a:p>
+            <a:pPr marL="800100" lvl="1" indent="-342900">
+              <a:lnSpc>
+                <a:spcPct val="150000"/>
+              </a:lnSpc>
+              <a:buFont typeface="+mj-lt"/>
+              <a:buAutoNum type="arabicPeriod"/>
+            </a:pPr>
+            <a:r>
+              <a:rPr lang="en-US" altLang="en-US" sz="1300">
+                <a:latin typeface="Arial" panose="020B0604020202020204" pitchFamily="34" charset="0"/>
+              </a:rPr>
+              <a:t>İstifadəçi checkbox-a klik edəndə → AJAX request göndərilir (PUT /change-status).</a:t>
+            </a:r>
+          </a:p>
+          <a:p>
+            <a:pPr marL="800100" lvl="1" indent="-342900">
+              <a:lnSpc>
+                <a:spcPct val="150000"/>
+              </a:lnSpc>
+              <a:buFont typeface="+mj-lt"/>
+              <a:buAutoNum type="arabicPeriod"/>
+            </a:pPr>
+            <a:r>
+              <a:rPr lang="en-US" altLang="en-US" sz="1300">
+                <a:latin typeface="Arial" panose="020B0604020202020204" pitchFamily="34" charset="0"/>
+              </a:rPr>
+              <a:t>Controller request-i alır, DB-də status dəyişir.</a:t>
+            </a:r>
+          </a:p>
+          <a:p>
+            <a:pPr marL="800100" lvl="1" indent="-342900">
+              <a:lnSpc>
+                <a:spcPct val="150000"/>
+              </a:lnSpc>
+              <a:buFont typeface="+mj-lt"/>
+              <a:buAutoNum type="arabicPeriod"/>
+            </a:pPr>
+            <a:r>
+              <a:rPr lang="en-US" altLang="en-US" sz="1300">
+                <a:latin typeface="Arial" panose="020B0604020202020204" pitchFamily="34" charset="0"/>
+              </a:rPr>
+              <a:t>Cavab JSON qaytarılır (Status has been updated!).</a:t>
+            </a:r>
+          </a:p>
+          <a:p>
+            <a:pPr>
+              <a:lnSpc>
+                <a:spcPct val="150000"/>
+              </a:lnSpc>
+              <a:buNone/>
+            </a:pPr>
+            <a:endParaRPr kumimoji="0" lang="en-US" altLang="en-US" sz="1300" b="0" i="0" u="none" strike="noStrike" cap="none" normalizeH="0" baseline="0">
+              <a:ln>
+                <a:noFill/>
+              </a:ln>
+              <a:solidFill>
+                <a:schemeClr val="tx1"/>
+              </a:solidFill>
+              <a:effectLst/>
+              <a:latin typeface="Arial" panose="020B0604020202020204" pitchFamily="34" charset="0"/>
+            </a:endParaRPr>
+          </a:p>
+          <a:p>
+            <a:pPr>
+              <a:lnSpc>
+                <a:spcPct val="150000"/>
+              </a:lnSpc>
+              <a:buNone/>
+            </a:pPr>
+            <a:endParaRPr kumimoji="0" lang="en-US" altLang="en-US" sz="1300" b="0" i="0" u="none" strike="noStrike" cap="none" normalizeH="0" baseline="0">
+              <a:ln>
+                <a:noFill/>
+              </a:ln>
+              <a:solidFill>
+                <a:schemeClr val="tx1"/>
+              </a:solidFill>
+              <a:effectLst/>
+              <a:latin typeface="Arial" panose="020B0604020202020204" pitchFamily="34" charset="0"/>
+            </a:endParaRPr>
+          </a:p>
+        </p:txBody>
+      </p:sp>
+    </p:spTree>
+    <p:extLst>
+      <p:ext uri="{BB962C8B-B14F-4D97-AF65-F5344CB8AC3E}">
+        <p14:creationId xmlns:p14="http://schemas.microsoft.com/office/powerpoint/2010/main" val="3095838342"/>
+      </p:ext>
+    </p:extLst>
+  </p:cSld>
+  <p:clrMapOvr>
+    <a:masterClrMapping/>
+  </p:clrMapOvr>
+</p:sld>
+</file>
+
+<file path=ppt/slides/slide6.xml><?xml version="1.0" encoding="utf-8"?>
+<p:sld xmlns:a="http://schemas.openxmlformats.org/drawingml/2006/main" xmlns:r="http://schemas.openxmlformats.org/officeDocument/2006/relationships" xmlns:p="http://schemas.openxmlformats.org/presentationml/2006/main">
+  <p:cSld>
+    <p:spTree>
+      <p:nvGrpSpPr>
+        <p:cNvPr id="1" name="">
+          <a:extLst>
+            <a:ext uri="{FF2B5EF4-FFF2-40B4-BE49-F238E27FC236}">
+              <a16:creationId xmlns:a16="http://schemas.microsoft.com/office/drawing/2014/main" id="{116ED99D-CE3D-A2D9-66E2-70854DEC6CBA}"/>
+            </a:ext>
+          </a:extLst>
+        </p:cNvPr>
+        <p:cNvGrpSpPr/>
+        <p:nvPr/>
+      </p:nvGrpSpPr>
+      <p:grpSpPr>
+        <a:xfrm>
+          <a:off x="0" y="0"/>
+          <a:ext cx="0" cy="0"/>
+          <a:chOff x="0" y="0"/>
+          <a:chExt cx="0" cy="0"/>
+        </a:xfrm>
+      </p:grpSpPr>
+      <p:sp>
+        <p:nvSpPr>
+          <p:cNvPr id="3" name="TextBox 2">
+            <a:extLst>
+              <a:ext uri="{FF2B5EF4-FFF2-40B4-BE49-F238E27FC236}">
+                <a16:creationId xmlns:a16="http://schemas.microsoft.com/office/drawing/2014/main" id="{B7A5F3B5-97D6-B9AF-0C9E-D34FFAB97AC5}"/>
+              </a:ext>
+            </a:extLst>
+          </p:cNvPr>
+          <p:cNvSpPr txBox="1"/>
+          <p:nvPr/>
+        </p:nvSpPr>
+        <p:spPr>
+          <a:xfrm>
+            <a:off x="217714" y="255046"/>
             <a:ext cx="11756571" cy="355354"/>
           </a:xfrm>
           <a:prstGeom prst="rect">
@@ -3559,7 +5133,7 @@
     </p:spTree>
     <p:extLst>
       <p:ext uri="{BB962C8B-B14F-4D97-AF65-F5344CB8AC3E}">
-        <p14:creationId xmlns:p14="http://schemas.microsoft.com/office/powerpoint/2010/main" val="3095838342"/>
+        <p14:creationId xmlns:p14="http://schemas.microsoft.com/office/powerpoint/2010/main" val="1718748490"/>
       </p:ext>
     </p:extLst>
   </p:cSld>

</xml_diff>